<commit_message>
added hyperlinks to dataset sources
</commit_message>
<xml_diff>
--- a/Calgary Traffic Midpoint Presentation.pptx
+++ b/Calgary Traffic Midpoint Presentation.pptx
@@ -4075,7 +4075,7 @@
           <p:nvPr>
             <p:extLst>
               <p:ext uri="{D42A27DB-BD31-4B8C-83A1-F6EECF244321}">
-                <p14:modId xmlns:p14="http://schemas.microsoft.com/office/powerpoint/2010/main" val="4044901852"/>
+                <p14:modId xmlns:p14="http://schemas.microsoft.com/office/powerpoint/2010/main" val="3404139762"/>
               </p:ext>
             </p:extLst>
           </p:nvPr>
@@ -4437,6 +4437,7 @@
                           <a:latin typeface="Public Sans" pitchFamily="34" charset="0"/>
                           <a:ea typeface="Public Sans" pitchFamily="34" charset="-122"/>
                           <a:cs typeface="Public Sans" pitchFamily="34" charset="-120"/>
+                          <a:hlinkClick r:id="rId3"/>
                         </a:rPr>
                         <a:t>City of Calgary Open Data</a:t>
                       </a:r>
@@ -4709,6 +4710,7 @@
                           <a:latin typeface="Public Sans" pitchFamily="34" charset="0"/>
                           <a:ea typeface="Public Sans" pitchFamily="34" charset="-122"/>
                           <a:cs typeface="Public Sans" pitchFamily="34" charset="-120"/>
+                          <a:hlinkClick r:id="rId4"/>
                         </a:rPr>
                         <a:t>City of Calgary Open Data</a:t>
                       </a:r>
@@ -4981,6 +4983,7 @@
                           <a:latin typeface="Public Sans" pitchFamily="34" charset="0"/>
                           <a:ea typeface="Public Sans" pitchFamily="34" charset="-122"/>
                           <a:cs typeface="Public Sans" pitchFamily="34" charset="-120"/>
+                          <a:hlinkClick r:id="rId5"/>
                         </a:rPr>
                         <a:t>City of Calgary Open Data</a:t>
                       </a:r>

</xml_diff>

<commit_message>
added rest of group member names; added references; fixed title capitalization
</commit_message>
<xml_diff>
--- a/Calgary Traffic Midpoint Presentation.pptx
+++ b/Calgary Traffic Midpoint Presentation.pptx
@@ -6,7 +6,7 @@
     <p:sldMasterId id="2147483654" r:id="rId2"/>
   </p:sldMasterIdLst>
   <p:notesMasterIdLst>
-    <p:notesMasterId r:id="rId12"/>
+    <p:notesMasterId r:id="rId13"/>
   </p:notesMasterIdLst>
   <p:sldIdLst>
     <p:sldId id="256" r:id="rId3"/>
@@ -17,7 +17,8 @@
     <p:sldId id="269" r:id="rId8"/>
     <p:sldId id="270" r:id="rId9"/>
     <p:sldId id="263" r:id="rId10"/>
-    <p:sldId id="268" r:id="rId11"/>
+    <p:sldId id="271" r:id="rId11"/>
+    <p:sldId id="268" r:id="rId12"/>
   </p:sldIdLst>
   <p:sldSz cx="12192000" cy="6858000"/>
   <p:notesSz cx="6858000" cy="12192000"/>
@@ -138,6 +139,7 @@
             <p14:sldId id="269"/>
             <p14:sldId id="270"/>
             <p14:sldId id="263"/>
+            <p14:sldId id="271"/>
             <p14:sldId id="268"/>
           </p14:sldIdLst>
         </p14:section>
@@ -373,6 +375,153 @@
 </p:notes>
 </file>
 
+<file path=ppt/notesSlides/notesSlide10.xml><?xml version="1.0" encoding="utf-8"?>
+<p:notes xmlns:a="http://schemas.openxmlformats.org/drawingml/2006/main" xmlns:r="http://schemas.openxmlformats.org/officeDocument/2006/relationships" xmlns:p="http://schemas.openxmlformats.org/presentationml/2006/main">
+  <p:cSld>
+    <p:spTree>
+      <p:nvGrpSpPr>
+        <p:cNvPr id="1" name=""/>
+        <p:cNvGrpSpPr/>
+        <p:nvPr/>
+      </p:nvGrpSpPr>
+      <p:grpSpPr>
+        <a:xfrm>
+          <a:off x="0" y="0"/>
+          <a:ext cx="0" cy="0"/>
+          <a:chOff x="0" y="0"/>
+          <a:chExt cx="0" cy="0"/>
+        </a:xfrm>
+      </p:grpSpPr>
+      <p:sp>
+        <p:nvSpPr>
+          <p:cNvPr id="2" name="Slide Image Placeholder 1"/>
+          <p:cNvSpPr>
+            <a:spLocks noGrp="1" noRot="1" noChangeAspect="1"/>
+          </p:cNvSpPr>
+          <p:nvPr>
+            <p:ph type="sldImg"/>
+          </p:nvPr>
+        </p:nvSpPr>
+        <p:spPr/>
+      </p:sp>
+      <p:sp>
+        <p:nvSpPr>
+          <p:cNvPr id="3" name="Notes Placeholder 2"/>
+          <p:cNvSpPr>
+            <a:spLocks noGrp="1"/>
+          </p:cNvSpPr>
+          <p:nvPr>
+            <p:ph type="body" idx="1"/>
+          </p:nvPr>
+        </p:nvSpPr>
+        <p:spPr/>
+        <p:txBody>
+          <a:bodyPr/>
+          <a:lstStyle/>
+          <a:p>
+            <a:r>
+              <a:rPr lang="en-US" dirty="0"/>
+              <a:t>[9:45 – 10:00] Thanks for listening. I’m happy to take questions, or to go back into the dashboard to look at any area you’re curious about.</a:t>
+            </a:r>
+          </a:p>
+        </p:txBody>
+      </p:sp>
+      <p:sp>
+        <p:nvSpPr>
+          <p:cNvPr id="4" name="Slide Number Placeholder 3"/>
+          <p:cNvSpPr>
+            <a:spLocks noGrp="1"/>
+          </p:cNvSpPr>
+          <p:nvPr>
+            <p:ph type="sldNum" sz="quarter" idx="10"/>
+          </p:nvPr>
+        </p:nvSpPr>
+        <p:spPr/>
+        <p:txBody>
+          <a:bodyPr/>
+          <a:lstStyle/>
+          <a:p>
+            <a:pPr marL="0" marR="0" lvl="0" indent="0" algn="l" defTabSz="914400" rtl="0" eaLnBrk="1" fontAlgn="auto" latinLnBrk="0" hangingPunct="1">
+              <a:lnSpc>
+                <a:spcPct val="100000"/>
+              </a:lnSpc>
+              <a:spcBef>
+                <a:spcPts val="0"/>
+              </a:spcBef>
+              <a:spcAft>
+                <a:spcPts val="0"/>
+              </a:spcAft>
+              <a:buClrTx/>
+              <a:buSzTx/>
+              <a:buFontTx/>
+              <a:buNone/>
+              <a:tabLst/>
+              <a:defRPr/>
+            </a:pPr>
+            <a:fld id="{F7021451-1387-4CA6-816F-3879F97B5CBC}" type="slidenum">
+              <a:rPr kumimoji="0" lang="en-US" sz="1800" b="0" i="0" u="none" strike="noStrike" kern="1200" cap="none" spc="0" normalizeH="0" baseline="0" noProof="0">
+                <a:ln>
+                  <a:noFill/>
+                </a:ln>
+                <a:solidFill>
+                  <a:prstClr val="black"/>
+                </a:solidFill>
+                <a:effectLst/>
+                <a:uLnTx/>
+                <a:uFillTx/>
+                <a:latin typeface="Aptos" panose="02110004020202020204"/>
+                <a:ea typeface="+mn-ea"/>
+                <a:cs typeface="+mn-cs"/>
+              </a:rPr>
+              <a:pPr marL="0" marR="0" lvl="0" indent="0" algn="l" defTabSz="914400" rtl="0" eaLnBrk="1" fontAlgn="auto" latinLnBrk="0" hangingPunct="1">
+                <a:lnSpc>
+                  <a:spcPct val="100000"/>
+                </a:lnSpc>
+                <a:spcBef>
+                  <a:spcPts val="0"/>
+                </a:spcBef>
+                <a:spcAft>
+                  <a:spcPts val="0"/>
+                </a:spcAft>
+                <a:buClrTx/>
+                <a:buSzTx/>
+                <a:buFontTx/>
+                <a:buNone/>
+                <a:tabLst/>
+                <a:defRPr/>
+              </a:pPr>
+              <a:t>10</a:t>
+            </a:fld>
+            <a:endParaRPr kumimoji="0" lang="en-US" sz="1800" b="0" i="0" u="none" strike="noStrike" kern="1200" cap="none" spc="0" normalizeH="0" baseline="0" noProof="0">
+              <a:ln>
+                <a:noFill/>
+              </a:ln>
+              <a:solidFill>
+                <a:prstClr val="black"/>
+              </a:solidFill>
+              <a:effectLst/>
+              <a:uLnTx/>
+              <a:uFillTx/>
+              <a:latin typeface="Aptos" panose="02110004020202020204"/>
+              <a:ea typeface="+mn-ea"/>
+              <a:cs typeface="+mn-cs"/>
+            </a:endParaRPr>
+          </a:p>
+        </p:txBody>
+      </p:sp>
+    </p:spTree>
+    <p:extLst>
+      <p:ext uri="{BB962C8B-B14F-4D97-AF65-F5344CB8AC3E}">
+        <p14:creationId xmlns:p14="http://schemas.microsoft.com/office/powerpoint/2010/main" val="1024086991"/>
+      </p:ext>
+    </p:extLst>
+  </p:cSld>
+  <p:clrMapOvr>
+    <a:masterClrMapping/>
+  </p:clrMapOvr>
+</p:notes>
+</file>
+
 <file path=ppt/notesSlides/notesSlide2.xml><?xml version="1.0" encoding="utf-8"?>
 <p:notes xmlns:a="http://schemas.openxmlformats.org/drawingml/2006/main" xmlns:r="http://schemas.openxmlformats.org/officeDocument/2006/relationships" xmlns:p="http://schemas.openxmlformats.org/presentationml/2006/main">
   <p:cSld>
@@ -1107,7 +1256,13 @@
   <p:cSld>
     <p:spTree>
       <p:nvGrpSpPr>
-        <p:cNvPr id="1" name=""/>
+        <p:cNvPr id="1" name="">
+          <a:extLst>
+            <a:ext uri="{FF2B5EF4-FFF2-40B4-BE49-F238E27FC236}">
+              <a16:creationId xmlns:a16="http://schemas.microsoft.com/office/drawing/2014/main" id="{F3E49255-B267-0EEA-0164-B0F4EACABB00}"/>
+            </a:ext>
+          </a:extLst>
+        </p:cNvPr>
         <p:cNvGrpSpPr/>
         <p:nvPr/>
       </p:nvGrpSpPr>
@@ -1121,7 +1276,13 @@
       </p:grpSpPr>
       <p:sp>
         <p:nvSpPr>
-          <p:cNvPr id="2" name="Slide Image Placeholder 1"/>
+          <p:cNvPr id="2" name="Slide Image Placeholder 1">
+            <a:extLst>
+              <a:ext uri="{FF2B5EF4-FFF2-40B4-BE49-F238E27FC236}">
+                <a16:creationId xmlns:a16="http://schemas.microsoft.com/office/drawing/2014/main" id="{B59CF68C-55CE-5CD1-E839-F6D4A9F5F8BA}"/>
+              </a:ext>
+            </a:extLst>
+          </p:cNvPr>
           <p:cNvSpPr>
             <a:spLocks noGrp="1" noRot="1" noChangeAspect="1"/>
           </p:cNvSpPr>
@@ -1133,7 +1294,13 @@
       </p:sp>
       <p:sp>
         <p:nvSpPr>
-          <p:cNvPr id="3" name="Notes Placeholder 2"/>
+          <p:cNvPr id="3" name="Notes Placeholder 2">
+            <a:extLst>
+              <a:ext uri="{FF2B5EF4-FFF2-40B4-BE49-F238E27FC236}">
+                <a16:creationId xmlns:a16="http://schemas.microsoft.com/office/drawing/2014/main" id="{3DF2CCF1-9E7C-B642-DBDB-D9783A878470}"/>
+              </a:ext>
+            </a:extLst>
+          </p:cNvPr>
           <p:cNvSpPr>
             <a:spLocks noGrp="1"/>
           </p:cNvSpPr>
@@ -1155,7 +1322,13 @@
       </p:sp>
       <p:sp>
         <p:nvSpPr>
-          <p:cNvPr id="4" name="Slide Number Placeholder 3"/>
+          <p:cNvPr id="4" name="Slide Number Placeholder 3">
+            <a:extLst>
+              <a:ext uri="{FF2B5EF4-FFF2-40B4-BE49-F238E27FC236}">
+                <a16:creationId xmlns:a16="http://schemas.microsoft.com/office/drawing/2014/main" id="{52360AA9-BD44-65E4-42F2-5E8C3841CC8E}"/>
+              </a:ext>
+            </a:extLst>
+          </p:cNvPr>
           <p:cNvSpPr>
             <a:spLocks noGrp="1"/>
           </p:cNvSpPr>
@@ -1239,7 +1412,7 @@
     </p:spTree>
     <p:extLst>
       <p:ext uri="{BB962C8B-B14F-4D97-AF65-F5344CB8AC3E}">
-        <p14:creationId xmlns:p14="http://schemas.microsoft.com/office/powerpoint/2010/main" val="1024086991"/>
+        <p14:creationId xmlns:p14="http://schemas.microsoft.com/office/powerpoint/2010/main" val="3174249228"/>
       </p:ext>
     </p:extLst>
   </p:cSld>
@@ -2948,18 +3121,7 @@
                 <a:ea typeface="Public Sans" pitchFamily="34" charset="-122"/>
                 <a:cs typeface="Public Sans" pitchFamily="34" charset="-120"/>
               </a:rPr>
-              <a:t>Adrian </a:t>
-            </a:r>
-            <a:r>
-              <a:rPr lang="en-US" sz="1400">
-                <a:solidFill>
-                  <a:srgbClr val="C9C7CF"/>
-                </a:solidFill>
-                <a:latin typeface="Public Sans" pitchFamily="34" charset="0"/>
-                <a:ea typeface="Public Sans" pitchFamily="34" charset="-122"/>
-                <a:cs typeface="Public Sans" pitchFamily="34" charset="-120"/>
-              </a:rPr>
-              <a:t>Julve, Kein </a:t>
+              <a:t>Adrian Julve, Kein </a:t>
             </a:r>
             <a:r>
               <a:rPr lang="en-US" sz="1400" dirty="0" err="1">
@@ -2970,7 +3132,7 @@
                 <a:ea typeface="Public Sans" pitchFamily="34" charset="-122"/>
                 <a:cs typeface="Public Sans" pitchFamily="34" charset="-120"/>
               </a:rPr>
-              <a:t>Ritarita, Xinqi Zha</a:t>
+              <a:t>Ritarita</a:t>
             </a:r>
             <a:r>
               <a:rPr lang="en-US" sz="1400" dirty="0">
@@ -2981,7 +3143,7 @@
                 <a:ea typeface="Public Sans" pitchFamily="34" charset="-122"/>
                 <a:cs typeface="Public Sans" pitchFamily="34" charset="-120"/>
               </a:rPr>
-              <a:t> · Data 201 · Oct 20</a:t>
+              <a:t>, Xinqi Zha, Carter S, Muna O · Data 201 · Oct 20</a:t>
             </a:r>
             <a:r>
               <a:rPr lang="en-US" sz="1400" baseline="30000" dirty="0">
@@ -3006,6 +3168,730 @@
               <a:t>, 2026</a:t>
             </a:r>
             <a:endParaRPr lang="en-US" sz="1400" dirty="0"/>
+          </a:p>
+        </p:txBody>
+      </p:sp>
+    </p:spTree>
+  </p:cSld>
+  <p:clrMapOvr>
+    <a:masterClrMapping/>
+  </p:clrMapOvr>
+</p:sld>
+</file>
+
+<file path=ppt/slides/slide10.xml><?xml version="1.0" encoding="utf-8"?>
+<p:sld xmlns:a="http://schemas.openxmlformats.org/drawingml/2006/main" xmlns:r="http://schemas.openxmlformats.org/officeDocument/2006/relationships" xmlns:p="http://schemas.openxmlformats.org/presentationml/2006/main">
+  <p:cSld>
+    <p:bg>
+      <p:bgPr>
+        <a:solidFill>
+          <a:srgbClr val="2B2B30"/>
+        </a:solidFill>
+        <a:effectLst/>
+      </p:bgPr>
+    </p:bg>
+    <p:spTree>
+      <p:nvGrpSpPr>
+        <p:cNvPr id="1" name=""/>
+        <p:cNvGrpSpPr/>
+        <p:nvPr/>
+      </p:nvGrpSpPr>
+      <p:grpSpPr>
+        <a:xfrm>
+          <a:off x="0" y="0"/>
+          <a:ext cx="0" cy="0"/>
+          <a:chOff x="0" y="0"/>
+          <a:chExt cx="0" cy="0"/>
+        </a:xfrm>
+      </p:grpSpPr>
+      <p:sp>
+        <p:nvSpPr>
+          <p:cNvPr id="2" name="Shape 0"/>
+          <p:cNvSpPr/>
+          <p:nvPr/>
+        </p:nvSpPr>
+        <p:spPr>
+          <a:xfrm>
+            <a:off x="8686800" y="1905000"/>
+            <a:ext cx="863600" cy="863600"/>
+          </a:xfrm>
+          <a:prstGeom prst="rect">
+            <a:avLst/>
+          </a:prstGeom>
+          <a:solidFill>
+            <a:srgbClr val="D47BA3"/>
+          </a:solidFill>
+          <a:ln/>
+        </p:spPr>
+        <p:txBody>
+          <a:bodyPr/>
+          <a:lstStyle/>
+          <a:p>
+            <a:pPr marL="0" marR="0" lvl="0" indent="0" algn="l" defTabSz="914400" rtl="0" eaLnBrk="1" fontAlgn="auto" latinLnBrk="0" hangingPunct="1">
+              <a:lnSpc>
+                <a:spcPct val="100000"/>
+              </a:lnSpc>
+              <a:spcBef>
+                <a:spcPts val="0"/>
+              </a:spcBef>
+              <a:spcAft>
+                <a:spcPts val="0"/>
+              </a:spcAft>
+              <a:buClrTx/>
+              <a:buSzTx/>
+              <a:buFontTx/>
+              <a:buNone/>
+              <a:tabLst/>
+              <a:defRPr/>
+            </a:pPr>
+            <a:endParaRPr kumimoji="0" lang="en-CA" sz="1800" b="0" i="0" u="none" strike="noStrike" kern="1200" cap="none" spc="0" normalizeH="0" baseline="0" noProof="0">
+              <a:ln>
+                <a:noFill/>
+              </a:ln>
+              <a:solidFill>
+                <a:srgbClr val="2B2B30"/>
+              </a:solidFill>
+              <a:effectLst/>
+              <a:uLnTx/>
+              <a:uFillTx/>
+              <a:latin typeface="Public Sans"/>
+              <a:ea typeface="+mn-ea"/>
+              <a:cs typeface="+mn-cs"/>
+            </a:endParaRPr>
+          </a:p>
+        </p:txBody>
+      </p:sp>
+      <p:sp>
+        <p:nvSpPr>
+          <p:cNvPr id="3" name="Shape 1"/>
+          <p:cNvSpPr/>
+          <p:nvPr/>
+        </p:nvSpPr>
+        <p:spPr>
+          <a:xfrm>
+            <a:off x="9601200" y="1905000"/>
+            <a:ext cx="863600" cy="863600"/>
+          </a:xfrm>
+          <a:prstGeom prst="rect">
+            <a:avLst/>
+          </a:prstGeom>
+          <a:solidFill>
+            <a:srgbClr val="9E6B92"/>
+          </a:solidFill>
+          <a:ln/>
+        </p:spPr>
+        <p:txBody>
+          <a:bodyPr/>
+          <a:lstStyle/>
+          <a:p>
+            <a:pPr marL="0" marR="0" lvl="0" indent="0" algn="l" defTabSz="914400" rtl="0" eaLnBrk="1" fontAlgn="auto" latinLnBrk="0" hangingPunct="1">
+              <a:lnSpc>
+                <a:spcPct val="100000"/>
+              </a:lnSpc>
+              <a:spcBef>
+                <a:spcPts val="0"/>
+              </a:spcBef>
+              <a:spcAft>
+                <a:spcPts val="0"/>
+              </a:spcAft>
+              <a:buClrTx/>
+              <a:buSzTx/>
+              <a:buFontTx/>
+              <a:buNone/>
+              <a:tabLst/>
+              <a:defRPr/>
+            </a:pPr>
+            <a:endParaRPr kumimoji="0" lang="en-CA" sz="1800" b="0" i="0" u="none" strike="noStrike" kern="1200" cap="none" spc="0" normalizeH="0" baseline="0" noProof="0">
+              <a:ln>
+                <a:noFill/>
+              </a:ln>
+              <a:solidFill>
+                <a:srgbClr val="2B2B30"/>
+              </a:solidFill>
+              <a:effectLst/>
+              <a:uLnTx/>
+              <a:uFillTx/>
+              <a:latin typeface="Public Sans"/>
+              <a:ea typeface="+mn-ea"/>
+              <a:cs typeface="+mn-cs"/>
+            </a:endParaRPr>
+          </a:p>
+        </p:txBody>
+      </p:sp>
+      <p:sp>
+        <p:nvSpPr>
+          <p:cNvPr id="4" name="Shape 2"/>
+          <p:cNvSpPr/>
+          <p:nvPr/>
+        </p:nvSpPr>
+        <p:spPr>
+          <a:xfrm>
+            <a:off x="10515600" y="1905000"/>
+            <a:ext cx="863600" cy="863600"/>
+          </a:xfrm>
+          <a:prstGeom prst="rect">
+            <a:avLst/>
+          </a:prstGeom>
+          <a:solidFill>
+            <a:srgbClr val="4A4A78"/>
+          </a:solidFill>
+          <a:ln/>
+        </p:spPr>
+        <p:txBody>
+          <a:bodyPr/>
+          <a:lstStyle/>
+          <a:p>
+            <a:pPr marL="0" marR="0" lvl="0" indent="0" algn="l" defTabSz="914400" rtl="0" eaLnBrk="1" fontAlgn="auto" latinLnBrk="0" hangingPunct="1">
+              <a:lnSpc>
+                <a:spcPct val="100000"/>
+              </a:lnSpc>
+              <a:spcBef>
+                <a:spcPts val="0"/>
+              </a:spcBef>
+              <a:spcAft>
+                <a:spcPts val="0"/>
+              </a:spcAft>
+              <a:buClrTx/>
+              <a:buSzTx/>
+              <a:buFontTx/>
+              <a:buNone/>
+              <a:tabLst/>
+              <a:defRPr/>
+            </a:pPr>
+            <a:endParaRPr kumimoji="0" lang="en-CA" sz="1800" b="0" i="0" u="none" strike="noStrike" kern="1200" cap="none" spc="0" normalizeH="0" baseline="0" noProof="0">
+              <a:ln>
+                <a:noFill/>
+              </a:ln>
+              <a:solidFill>
+                <a:srgbClr val="2B2B30"/>
+              </a:solidFill>
+              <a:effectLst/>
+              <a:uLnTx/>
+              <a:uFillTx/>
+              <a:latin typeface="Public Sans"/>
+              <a:ea typeface="+mn-ea"/>
+              <a:cs typeface="+mn-cs"/>
+            </a:endParaRPr>
+          </a:p>
+        </p:txBody>
+      </p:sp>
+      <p:sp>
+        <p:nvSpPr>
+          <p:cNvPr id="5" name="Shape 3"/>
+          <p:cNvSpPr/>
+          <p:nvPr/>
+        </p:nvSpPr>
+        <p:spPr>
+          <a:xfrm>
+            <a:off x="8686800" y="2819400"/>
+            <a:ext cx="863600" cy="863600"/>
+          </a:xfrm>
+          <a:prstGeom prst="rect">
+            <a:avLst/>
+          </a:prstGeom>
+          <a:solidFill>
+            <a:srgbClr val="DBB7CF"/>
+          </a:solidFill>
+          <a:ln/>
+        </p:spPr>
+        <p:txBody>
+          <a:bodyPr/>
+          <a:lstStyle/>
+          <a:p>
+            <a:pPr marL="0" marR="0" lvl="0" indent="0" algn="l" defTabSz="914400" rtl="0" eaLnBrk="1" fontAlgn="auto" latinLnBrk="0" hangingPunct="1">
+              <a:lnSpc>
+                <a:spcPct val="100000"/>
+              </a:lnSpc>
+              <a:spcBef>
+                <a:spcPts val="0"/>
+              </a:spcBef>
+              <a:spcAft>
+                <a:spcPts val="0"/>
+              </a:spcAft>
+              <a:buClrTx/>
+              <a:buSzTx/>
+              <a:buFontTx/>
+              <a:buNone/>
+              <a:tabLst/>
+              <a:defRPr/>
+            </a:pPr>
+            <a:endParaRPr kumimoji="0" lang="en-CA" sz="1800" b="0" i="0" u="none" strike="noStrike" kern="1200" cap="none" spc="0" normalizeH="0" baseline="0" noProof="0">
+              <a:ln>
+                <a:noFill/>
+              </a:ln>
+              <a:solidFill>
+                <a:srgbClr val="2B2B30"/>
+              </a:solidFill>
+              <a:effectLst/>
+              <a:uLnTx/>
+              <a:uFillTx/>
+              <a:latin typeface="Public Sans"/>
+              <a:ea typeface="+mn-ea"/>
+              <a:cs typeface="+mn-cs"/>
+            </a:endParaRPr>
+          </a:p>
+        </p:txBody>
+      </p:sp>
+      <p:sp>
+        <p:nvSpPr>
+          <p:cNvPr id="6" name="Shape 4"/>
+          <p:cNvSpPr/>
+          <p:nvPr/>
+        </p:nvSpPr>
+        <p:spPr>
+          <a:xfrm>
+            <a:off x="9601200" y="2819400"/>
+            <a:ext cx="863600" cy="863600"/>
+          </a:xfrm>
+          <a:prstGeom prst="rect">
+            <a:avLst/>
+          </a:prstGeom>
+          <a:solidFill>
+            <a:srgbClr val="A3A3C8"/>
+          </a:solidFill>
+          <a:ln/>
+        </p:spPr>
+        <p:txBody>
+          <a:bodyPr/>
+          <a:lstStyle/>
+          <a:p>
+            <a:pPr marL="0" marR="0" lvl="0" indent="0" algn="l" defTabSz="914400" rtl="0" eaLnBrk="1" fontAlgn="auto" latinLnBrk="0" hangingPunct="1">
+              <a:lnSpc>
+                <a:spcPct val="100000"/>
+              </a:lnSpc>
+              <a:spcBef>
+                <a:spcPts val="0"/>
+              </a:spcBef>
+              <a:spcAft>
+                <a:spcPts val="0"/>
+              </a:spcAft>
+              <a:buClrTx/>
+              <a:buSzTx/>
+              <a:buFontTx/>
+              <a:buNone/>
+              <a:tabLst/>
+              <a:defRPr/>
+            </a:pPr>
+            <a:endParaRPr kumimoji="0" lang="en-CA" sz="1800" b="0" i="0" u="none" strike="noStrike" kern="1200" cap="none" spc="0" normalizeH="0" baseline="0" noProof="0">
+              <a:ln>
+                <a:noFill/>
+              </a:ln>
+              <a:solidFill>
+                <a:srgbClr val="2B2B30"/>
+              </a:solidFill>
+              <a:effectLst/>
+              <a:uLnTx/>
+              <a:uFillTx/>
+              <a:latin typeface="Public Sans"/>
+              <a:ea typeface="+mn-ea"/>
+              <a:cs typeface="+mn-cs"/>
+            </a:endParaRPr>
+          </a:p>
+        </p:txBody>
+      </p:sp>
+      <p:sp>
+        <p:nvSpPr>
+          <p:cNvPr id="7" name="Shape 5"/>
+          <p:cNvSpPr/>
+          <p:nvPr/>
+        </p:nvSpPr>
+        <p:spPr>
+          <a:xfrm>
+            <a:off x="10515600" y="2819400"/>
+            <a:ext cx="863600" cy="863600"/>
+          </a:xfrm>
+          <a:prstGeom prst="rect">
+            <a:avLst/>
+          </a:prstGeom>
+          <a:solidFill>
+            <a:srgbClr val="56709E"/>
+          </a:solidFill>
+          <a:ln/>
+        </p:spPr>
+        <p:txBody>
+          <a:bodyPr/>
+          <a:lstStyle/>
+          <a:p>
+            <a:pPr marL="0" marR="0" lvl="0" indent="0" algn="l" defTabSz="914400" rtl="0" eaLnBrk="1" fontAlgn="auto" latinLnBrk="0" hangingPunct="1">
+              <a:lnSpc>
+                <a:spcPct val="100000"/>
+              </a:lnSpc>
+              <a:spcBef>
+                <a:spcPts val="0"/>
+              </a:spcBef>
+              <a:spcAft>
+                <a:spcPts val="0"/>
+              </a:spcAft>
+              <a:buClrTx/>
+              <a:buSzTx/>
+              <a:buFontTx/>
+              <a:buNone/>
+              <a:tabLst/>
+              <a:defRPr/>
+            </a:pPr>
+            <a:endParaRPr kumimoji="0" lang="en-CA" sz="1800" b="0" i="0" u="none" strike="noStrike" kern="1200" cap="none" spc="0" normalizeH="0" baseline="0" noProof="0">
+              <a:ln>
+                <a:noFill/>
+              </a:ln>
+              <a:solidFill>
+                <a:srgbClr val="2B2B30"/>
+              </a:solidFill>
+              <a:effectLst/>
+              <a:uLnTx/>
+              <a:uFillTx/>
+              <a:latin typeface="Public Sans"/>
+              <a:ea typeface="+mn-ea"/>
+              <a:cs typeface="+mn-cs"/>
+            </a:endParaRPr>
+          </a:p>
+        </p:txBody>
+      </p:sp>
+      <p:sp>
+        <p:nvSpPr>
+          <p:cNvPr id="8" name="Shape 6"/>
+          <p:cNvSpPr/>
+          <p:nvPr/>
+        </p:nvSpPr>
+        <p:spPr>
+          <a:xfrm>
+            <a:off x="8686800" y="3733800"/>
+            <a:ext cx="863600" cy="863600"/>
+          </a:xfrm>
+          <a:prstGeom prst="rect">
+            <a:avLst/>
+          </a:prstGeom>
+          <a:solidFill>
+            <a:srgbClr val="EAE1D2"/>
+          </a:solidFill>
+          <a:ln/>
+        </p:spPr>
+        <p:txBody>
+          <a:bodyPr/>
+          <a:lstStyle/>
+          <a:p>
+            <a:pPr marL="0" marR="0" lvl="0" indent="0" algn="l" defTabSz="914400" rtl="0" eaLnBrk="1" fontAlgn="auto" latinLnBrk="0" hangingPunct="1">
+              <a:lnSpc>
+                <a:spcPct val="100000"/>
+              </a:lnSpc>
+              <a:spcBef>
+                <a:spcPts val="0"/>
+              </a:spcBef>
+              <a:spcAft>
+                <a:spcPts val="0"/>
+              </a:spcAft>
+              <a:buClrTx/>
+              <a:buSzTx/>
+              <a:buFontTx/>
+              <a:buNone/>
+              <a:tabLst/>
+              <a:defRPr/>
+            </a:pPr>
+            <a:endParaRPr kumimoji="0" lang="en-CA" sz="1800" b="0" i="0" u="none" strike="noStrike" kern="1200" cap="none" spc="0" normalizeH="0" baseline="0" noProof="0">
+              <a:ln>
+                <a:noFill/>
+              </a:ln>
+              <a:solidFill>
+                <a:srgbClr val="2B2B30"/>
+              </a:solidFill>
+              <a:effectLst/>
+              <a:uLnTx/>
+              <a:uFillTx/>
+              <a:latin typeface="Public Sans"/>
+              <a:ea typeface="+mn-ea"/>
+              <a:cs typeface="+mn-cs"/>
+            </a:endParaRPr>
+          </a:p>
+        </p:txBody>
+      </p:sp>
+      <p:sp>
+        <p:nvSpPr>
+          <p:cNvPr id="9" name="Shape 7"/>
+          <p:cNvSpPr/>
+          <p:nvPr/>
+        </p:nvSpPr>
+        <p:spPr>
+          <a:xfrm>
+            <a:off x="9601200" y="3733800"/>
+            <a:ext cx="863600" cy="863600"/>
+          </a:xfrm>
+          <a:prstGeom prst="rect">
+            <a:avLst/>
+          </a:prstGeom>
+          <a:solidFill>
+            <a:srgbClr val="B5C0DA"/>
+          </a:solidFill>
+          <a:ln/>
+        </p:spPr>
+        <p:txBody>
+          <a:bodyPr/>
+          <a:lstStyle/>
+          <a:p>
+            <a:pPr marL="0" marR="0" lvl="0" indent="0" algn="l" defTabSz="914400" rtl="0" eaLnBrk="1" fontAlgn="auto" latinLnBrk="0" hangingPunct="1">
+              <a:lnSpc>
+                <a:spcPct val="100000"/>
+              </a:lnSpc>
+              <a:spcBef>
+                <a:spcPts val="0"/>
+              </a:spcBef>
+              <a:spcAft>
+                <a:spcPts val="0"/>
+              </a:spcAft>
+              <a:buClrTx/>
+              <a:buSzTx/>
+              <a:buFontTx/>
+              <a:buNone/>
+              <a:tabLst/>
+              <a:defRPr/>
+            </a:pPr>
+            <a:endParaRPr kumimoji="0" lang="en-CA" sz="1800" b="0" i="0" u="none" strike="noStrike" kern="1200" cap="none" spc="0" normalizeH="0" baseline="0" noProof="0">
+              <a:ln>
+                <a:noFill/>
+              </a:ln>
+              <a:solidFill>
+                <a:srgbClr val="2B2B30"/>
+              </a:solidFill>
+              <a:effectLst/>
+              <a:uLnTx/>
+              <a:uFillTx/>
+              <a:latin typeface="Public Sans"/>
+              <a:ea typeface="+mn-ea"/>
+              <a:cs typeface="+mn-cs"/>
+            </a:endParaRPr>
+          </a:p>
+        </p:txBody>
+      </p:sp>
+      <p:sp>
+        <p:nvSpPr>
+          <p:cNvPr id="10" name="Shape 8"/>
+          <p:cNvSpPr/>
+          <p:nvPr/>
+        </p:nvSpPr>
+        <p:spPr>
+          <a:xfrm>
+            <a:off x="10515600" y="3733800"/>
+            <a:ext cx="863600" cy="863600"/>
+          </a:xfrm>
+          <a:prstGeom prst="rect">
+            <a:avLst/>
+          </a:prstGeom>
+          <a:solidFill>
+            <a:srgbClr val="6C83B5"/>
+          </a:solidFill>
+          <a:ln/>
+        </p:spPr>
+        <p:txBody>
+          <a:bodyPr/>
+          <a:lstStyle/>
+          <a:p>
+            <a:pPr marL="0" marR="0" lvl="0" indent="0" algn="l" defTabSz="914400" rtl="0" eaLnBrk="1" fontAlgn="auto" latinLnBrk="0" hangingPunct="1">
+              <a:lnSpc>
+                <a:spcPct val="100000"/>
+              </a:lnSpc>
+              <a:spcBef>
+                <a:spcPts val="0"/>
+              </a:spcBef>
+              <a:spcAft>
+                <a:spcPts val="0"/>
+              </a:spcAft>
+              <a:buClrTx/>
+              <a:buSzTx/>
+              <a:buFontTx/>
+              <a:buNone/>
+              <a:tabLst/>
+              <a:defRPr/>
+            </a:pPr>
+            <a:endParaRPr kumimoji="0" lang="en-CA" sz="1800" b="0" i="0" u="none" strike="noStrike" kern="1200" cap="none" spc="0" normalizeH="0" baseline="0" noProof="0">
+              <a:ln>
+                <a:noFill/>
+              </a:ln>
+              <a:solidFill>
+                <a:srgbClr val="2B2B30"/>
+              </a:solidFill>
+              <a:effectLst/>
+              <a:uLnTx/>
+              <a:uFillTx/>
+              <a:latin typeface="Public Sans"/>
+              <a:ea typeface="+mn-ea"/>
+              <a:cs typeface="+mn-cs"/>
+            </a:endParaRPr>
+          </a:p>
+        </p:txBody>
+      </p:sp>
+      <p:sp>
+        <p:nvSpPr>
+          <p:cNvPr id="11" name="Text 9"/>
+          <p:cNvSpPr>
+            <a:spLocks noGrp="1"/>
+          </p:cNvSpPr>
+          <p:nvPr>
+            <p:ph type="title"/>
+          </p:nvPr>
+        </p:nvSpPr>
+        <p:spPr>
+          <a:xfrm>
+            <a:off x="812800" y="2771142"/>
+            <a:ext cx="7194550" cy="695960"/>
+          </a:xfrm>
+          <a:prstGeom prst="rect">
+            <a:avLst/>
+          </a:prstGeom>
+          <a:noFill/>
+          <a:ln/>
+        </p:spPr>
+        <p:txBody>
+          <a:bodyPr wrap="square" lIns="0" tIns="0" rIns="0" bIns="0" rtlCol="0" anchor="t">
+            <a:normAutofit/>
+          </a:bodyPr>
+          <a:lstStyle/>
+          <a:p>
+            <a:pPr marL="0" indent="0" algn="l">
+              <a:lnSpc>
+                <a:spcPts val="5280"/>
+              </a:lnSpc>
+              <a:buNone/>
+            </a:pPr>
+            <a:r>
+              <a:rPr lang="en-US" sz="4800" b="1" i="0" dirty="0">
+                <a:solidFill>
+                  <a:srgbClr val="F4EEE3"/>
+                </a:solidFill>
+                <a:latin typeface="Libre Baskerville" pitchFamily="18" charset="0"/>
+                <a:ea typeface="Libre Baskerville" pitchFamily="18" charset="-122"/>
+                <a:cs typeface="Libre Baskerville" pitchFamily="18" charset="-120"/>
+              </a:rPr>
+              <a:t>Thank you</a:t>
+            </a:r>
+            <a:endParaRPr lang="en-US" sz="4800" dirty="0"/>
+          </a:p>
+        </p:txBody>
+      </p:sp>
+      <p:sp>
+        <p:nvSpPr>
+          <p:cNvPr id="12" name="Text 10"/>
+          <p:cNvSpPr/>
+          <p:nvPr/>
+        </p:nvSpPr>
+        <p:spPr>
+          <a:xfrm>
+            <a:off x="812800" y="3695700"/>
+            <a:ext cx="7194550" cy="416560"/>
+          </a:xfrm>
+          <a:prstGeom prst="rect">
+            <a:avLst/>
+          </a:prstGeom>
+          <a:noFill/>
+          <a:ln/>
+        </p:spPr>
+        <p:txBody>
+          <a:bodyPr wrap="square" lIns="0" tIns="0" rIns="0" bIns="0" rtlCol="0" anchor="t">
+            <a:normAutofit/>
+          </a:bodyPr>
+          <a:lstStyle/>
+          <a:p>
+            <a:pPr marL="0" marR="0" lvl="0" indent="0" algn="l" defTabSz="914400" rtl="0" eaLnBrk="1" fontAlgn="auto" latinLnBrk="0" hangingPunct="1">
+              <a:lnSpc>
+                <a:spcPts val="3080"/>
+              </a:lnSpc>
+              <a:spcBef>
+                <a:spcPts val="0"/>
+              </a:spcBef>
+              <a:spcAft>
+                <a:spcPts val="0"/>
+              </a:spcAft>
+              <a:buClrTx/>
+              <a:buSzTx/>
+              <a:buFontTx/>
+              <a:buNone/>
+              <a:tabLst/>
+              <a:defRPr/>
+            </a:pPr>
+            <a:r>
+              <a:rPr kumimoji="0" lang="en-US" sz="2200" b="0" i="0" u="none" strike="noStrike" kern="1200" cap="none" spc="0" normalizeH="0" baseline="0" noProof="0" dirty="0">
+                <a:ln>
+                  <a:noFill/>
+                </a:ln>
+                <a:solidFill>
+                  <a:srgbClr val="E39BBE"/>
+                </a:solidFill>
+                <a:effectLst/>
+                <a:uLnTx/>
+                <a:uFillTx/>
+                <a:latin typeface="Public Sans" pitchFamily="34" charset="0"/>
+                <a:ea typeface="Public Sans" pitchFamily="34" charset="-122"/>
+                <a:cs typeface="Public Sans" pitchFamily="34" charset="-120"/>
+              </a:rPr>
+              <a:t>Questions?</a:t>
+            </a:r>
+            <a:endParaRPr kumimoji="0" lang="en-US" sz="2200" b="0" i="0" u="none" strike="noStrike" kern="1200" cap="none" spc="0" normalizeH="0" baseline="0" noProof="0" dirty="0">
+              <a:ln>
+                <a:noFill/>
+              </a:ln>
+              <a:solidFill>
+                <a:srgbClr val="2B2B30"/>
+              </a:solidFill>
+              <a:effectLst/>
+              <a:uLnTx/>
+              <a:uFillTx/>
+              <a:ea typeface="+mn-ea"/>
+              <a:cs typeface="+mn-cs"/>
+            </a:endParaRPr>
+          </a:p>
+        </p:txBody>
+      </p:sp>
+      <p:sp>
+        <p:nvSpPr>
+          <p:cNvPr id="13" name="Text 11"/>
+          <p:cNvSpPr/>
+          <p:nvPr/>
+        </p:nvSpPr>
+        <p:spPr>
+          <a:xfrm>
+            <a:off x="812800" y="5999479"/>
+            <a:ext cx="7194550" cy="274320"/>
+          </a:xfrm>
+          <a:prstGeom prst="rect">
+            <a:avLst/>
+          </a:prstGeom>
+          <a:noFill/>
+          <a:ln/>
+        </p:spPr>
+        <p:txBody>
+          <a:bodyPr wrap="square" lIns="0" tIns="0" rIns="0" bIns="0" rtlCol="0" anchor="t">
+            <a:normAutofit/>
+          </a:bodyPr>
+          <a:lstStyle/>
+          <a:p>
+            <a:pPr marL="0" marR="0" lvl="0" indent="0" algn="l" defTabSz="914400" rtl="0" eaLnBrk="1" fontAlgn="auto" latinLnBrk="0" hangingPunct="1">
+              <a:lnSpc>
+                <a:spcPts val="1960"/>
+              </a:lnSpc>
+              <a:spcBef>
+                <a:spcPts val="0"/>
+              </a:spcBef>
+              <a:spcAft>
+                <a:spcPts val="0"/>
+              </a:spcAft>
+              <a:buClrTx/>
+              <a:buSzTx/>
+              <a:buFontTx/>
+              <a:buNone/>
+              <a:tabLst/>
+              <a:defRPr/>
+            </a:pPr>
+            <a:endParaRPr kumimoji="0" lang="en-US" sz="1400" b="0" i="0" u="none" strike="noStrike" kern="1200" cap="none" spc="0" normalizeH="0" baseline="0" noProof="0" dirty="0">
+              <a:ln>
+                <a:noFill/>
+              </a:ln>
+              <a:solidFill>
+                <a:srgbClr val="2B2B30"/>
+              </a:solidFill>
+              <a:effectLst/>
+              <a:uLnTx/>
+              <a:uFillTx/>
+              <a:latin typeface="Public Sans"/>
+              <a:ea typeface="+mn-ea"/>
+              <a:cs typeface="+mn-cs"/>
+            </a:endParaRPr>
           </a:p>
         </p:txBody>
       </p:sp>
@@ -3071,7 +3957,7 @@
                 <a:ea typeface="Libre Baskerville" pitchFamily="34" charset="-122"/>
                 <a:cs typeface="Libre Baskerville" pitchFamily="34" charset="-120"/>
               </a:rPr>
-              <a:t>Project overview</a:t>
+              <a:t>Project Overview</a:t>
             </a:r>
             <a:endParaRPr lang="en-US" sz="3200" dirty="0"/>
           </a:p>
@@ -3539,7 +4425,7 @@
                 <a:ea typeface="Libre Baskerville" pitchFamily="34" charset="-122"/>
                 <a:cs typeface="Libre Baskerville" pitchFamily="34" charset="-120"/>
               </a:rPr>
-              <a:t>Analysis questions</a:t>
+              <a:t>Analysis Questions</a:t>
             </a:r>
             <a:endParaRPr lang="en-US" sz="3200" dirty="0"/>
           </a:p>
@@ -4065,7 +4951,7 @@
                 <a:ea typeface="Libre Baskerville" pitchFamily="18" charset="-122"/>
                 <a:cs typeface="Libre Baskerville" pitchFamily="18" charset="-120"/>
               </a:rPr>
-              <a:t>Datasets obtained</a:t>
+              <a:t>Datasets Obtained</a:t>
             </a:r>
             <a:endParaRPr lang="en-US" sz="3200" dirty="0"/>
           </a:p>
@@ -4077,7 +4963,13 @@
           <p:cNvGraphicFramePr>
             <a:graphicFrameLocks noGrp="1"/>
           </p:cNvGraphicFramePr>
-          <p:nvPr/>
+          <p:nvPr>
+            <p:extLst>
+              <p:ext uri="{D42A27DB-BD31-4B8C-83A1-F6EECF244321}">
+                <p14:modId xmlns:p14="http://schemas.microsoft.com/office/powerpoint/2010/main" val="1614802144"/>
+              </p:ext>
+            </p:extLst>
+          </p:nvPr>
         </p:nvGraphicFramePr>
         <p:xfrm>
           <a:off x="825500" y="1597620"/>
@@ -4580,7 +5472,18 @@
                         </a:rPr>
                         <a:t>City of Calgary Open Data</a:t>
                       </a:r>
-                      <a:endParaRPr lang="en-US" sz="1300" dirty="0">
+                      <a:r>
+                        <a:rPr lang="en-US" sz="1300" baseline="30000" dirty="0">
+                          <a:solidFill>
+                            <a:srgbClr val="2B2B30"/>
+                          </a:solidFill>
+                          <a:latin typeface="Public Sans" pitchFamily="34" charset="0"/>
+                          <a:ea typeface="Public Sans" pitchFamily="34" charset="-122"/>
+                          <a:cs typeface="Public Sans" pitchFamily="34" charset="-120"/>
+                        </a:rPr>
+                        <a:t>1</a:t>
+                      </a:r>
+                      <a:endParaRPr lang="en-US" sz="1300" baseline="30000" dirty="0">
                         <a:latin typeface="Public Sans" charset="0"/>
                         <a:ea typeface="Public Sans" charset="0"/>
                         <a:cs typeface="Public Sans" charset="0"/>
@@ -4942,7 +5845,18 @@
                         </a:rPr>
                         <a:t>City of Calgary Open Data</a:t>
                       </a:r>
-                      <a:endParaRPr lang="en-US" sz="1300" dirty="0">
+                      <a:r>
+                        <a:rPr lang="en-US" sz="1300" baseline="30000" dirty="0">
+                          <a:solidFill>
+                            <a:srgbClr val="2B2B30"/>
+                          </a:solidFill>
+                          <a:latin typeface="Public Sans" pitchFamily="34" charset="0"/>
+                          <a:ea typeface="Public Sans" pitchFamily="34" charset="-122"/>
+                          <a:cs typeface="Public Sans" pitchFamily="34" charset="-120"/>
+                        </a:rPr>
+                        <a:t>2</a:t>
+                      </a:r>
+                      <a:endParaRPr lang="en-US" sz="1300" baseline="30000" dirty="0">
                         <a:latin typeface="Public Sans" charset="0"/>
                         <a:ea typeface="Public Sans" charset="0"/>
                         <a:cs typeface="Public Sans" charset="0"/>
@@ -5304,7 +6218,18 @@
                         </a:rPr>
                         <a:t>City of Calgary Open Data</a:t>
                       </a:r>
-                      <a:endParaRPr lang="en-US" sz="1300" dirty="0">
+                      <a:r>
+                        <a:rPr lang="en-US" sz="1300" baseline="30000" dirty="0">
+                          <a:solidFill>
+                            <a:srgbClr val="2B2B30"/>
+                          </a:solidFill>
+                          <a:latin typeface="Public Sans" pitchFamily="34" charset="0"/>
+                          <a:ea typeface="Public Sans" pitchFamily="34" charset="-122"/>
+                          <a:cs typeface="Public Sans" pitchFamily="34" charset="-120"/>
+                        </a:rPr>
+                        <a:t>3</a:t>
+                      </a:r>
+                      <a:endParaRPr lang="en-US" sz="1300" baseline="30000" dirty="0">
                         <a:latin typeface="Public Sans" charset="0"/>
                         <a:ea typeface="Public Sans" charset="0"/>
                         <a:cs typeface="Public Sans" charset="0"/>
@@ -5643,7 +6568,7 @@
                 <a:ea typeface="Libre Baskerville" pitchFamily="18" charset="-122"/>
                 <a:cs typeface="Libre Baskerville" pitchFamily="18" charset="-120"/>
               </a:rPr>
-              <a:t>Data wrangling and cleaning</a:t>
+              <a:t>Data Wrangling and Cleaning</a:t>
             </a:r>
             <a:endParaRPr lang="en-US" sz="3200" dirty="0"/>
           </a:p>
@@ -7091,7 +8016,29 @@
                 <a:ea typeface="Libre Baskerville" pitchFamily="18" charset="-122"/>
                 <a:cs typeface="Libre Baskerville" pitchFamily="18" charset="-120"/>
               </a:rPr>
-              <a:t>The dashboard so far</a:t>
+              <a:t>The Dashboard So </a:t>
+            </a:r>
+            <a:r>
+              <a:rPr lang="en-US" b="1" dirty="0">
+                <a:solidFill>
+                  <a:srgbClr val="F4EEE3"/>
+                </a:solidFill>
+                <a:latin typeface="Libre Baskerville" pitchFamily="18" charset="0"/>
+                <a:ea typeface="Libre Baskerville" pitchFamily="18" charset="-122"/>
+                <a:cs typeface="Libre Baskerville" pitchFamily="18" charset="-120"/>
+              </a:rPr>
+              <a:t>F</a:t>
+            </a:r>
+            <a:r>
+              <a:rPr lang="en-US" sz="3200" b="1" i="0" dirty="0">
+                <a:solidFill>
+                  <a:srgbClr val="F4EEE3"/>
+                </a:solidFill>
+                <a:latin typeface="Libre Baskerville" pitchFamily="18" charset="0"/>
+                <a:ea typeface="Libre Baskerville" pitchFamily="18" charset="-122"/>
+                <a:cs typeface="Libre Baskerville" pitchFamily="18" charset="-120"/>
+              </a:rPr>
+              <a:t>ar</a:t>
             </a:r>
             <a:endParaRPr lang="en-US" sz="3200" dirty="0"/>
           </a:p>
@@ -7472,7 +8419,7 @@
                 <a:ea typeface="Libre Baskerville" pitchFamily="34" charset="-122"/>
                 <a:cs typeface="Libre Baskerville" pitchFamily="34" charset="-120"/>
               </a:rPr>
-              <a:t>Findings: where and who</a:t>
+              <a:t>Findings: Where and Who</a:t>
             </a:r>
             <a:endParaRPr lang="en-US" sz="3200" dirty="0"/>
           </a:p>
@@ -8227,7 +9174,7 @@
                 <a:ea typeface="Libre Baskerville" pitchFamily="34" charset="-122"/>
                 <a:cs typeface="Libre Baskerville" pitchFamily="34" charset="-120"/>
               </a:rPr>
-              <a:t>Findings: when</a:t>
+              <a:t>Findings: When</a:t>
             </a:r>
             <a:endParaRPr lang="en-US" sz="3200" dirty="0"/>
           </a:p>
@@ -8402,7 +9349,13 @@
     </p:bg>
     <p:spTree>
       <p:nvGrpSpPr>
-        <p:cNvPr id="1" name=""/>
+        <p:cNvPr id="1" name="">
+          <a:extLst>
+            <a:ext uri="{FF2B5EF4-FFF2-40B4-BE49-F238E27FC236}">
+              <a16:creationId xmlns:a16="http://schemas.microsoft.com/office/drawing/2014/main" id="{3083BA66-95C1-FCAC-5F22-7E9219F23BD2}"/>
+            </a:ext>
+          </a:extLst>
+        </p:cNvPr>
         <p:cNvGrpSpPr/>
         <p:nvPr/>
       </p:nvGrpSpPr>
@@ -8416,7 +9369,13 @@
       </p:grpSpPr>
       <p:sp>
         <p:nvSpPr>
-          <p:cNvPr id="2" name="Shape 0"/>
+          <p:cNvPr id="2" name="Shape 0">
+            <a:extLst>
+              <a:ext uri="{FF2B5EF4-FFF2-40B4-BE49-F238E27FC236}">
+                <a16:creationId xmlns:a16="http://schemas.microsoft.com/office/drawing/2014/main" id="{20E75FCF-9109-CBAC-7300-EB6BB490113A}"/>
+              </a:ext>
+            </a:extLst>
+          </p:cNvPr>
           <p:cNvSpPr/>
           <p:nvPr/>
         </p:nvSpPr>
@@ -8473,7 +9432,13 @@
       </p:sp>
       <p:sp>
         <p:nvSpPr>
-          <p:cNvPr id="3" name="Shape 1"/>
+          <p:cNvPr id="3" name="Shape 1">
+            <a:extLst>
+              <a:ext uri="{FF2B5EF4-FFF2-40B4-BE49-F238E27FC236}">
+                <a16:creationId xmlns:a16="http://schemas.microsoft.com/office/drawing/2014/main" id="{1A159B36-C54E-D6BC-9882-9D858DBF5F5F}"/>
+              </a:ext>
+            </a:extLst>
+          </p:cNvPr>
           <p:cNvSpPr/>
           <p:nvPr/>
         </p:nvSpPr>
@@ -8530,7 +9495,13 @@
       </p:sp>
       <p:sp>
         <p:nvSpPr>
-          <p:cNvPr id="4" name="Shape 2"/>
+          <p:cNvPr id="4" name="Shape 2">
+            <a:extLst>
+              <a:ext uri="{FF2B5EF4-FFF2-40B4-BE49-F238E27FC236}">
+                <a16:creationId xmlns:a16="http://schemas.microsoft.com/office/drawing/2014/main" id="{37B0A929-6DB5-1ABD-CB5A-B09134A32412}"/>
+              </a:ext>
+            </a:extLst>
+          </p:cNvPr>
           <p:cNvSpPr/>
           <p:nvPr/>
         </p:nvSpPr>
@@ -8587,7 +9558,13 @@
       </p:sp>
       <p:sp>
         <p:nvSpPr>
-          <p:cNvPr id="5" name="Shape 3"/>
+          <p:cNvPr id="5" name="Shape 3">
+            <a:extLst>
+              <a:ext uri="{FF2B5EF4-FFF2-40B4-BE49-F238E27FC236}">
+                <a16:creationId xmlns:a16="http://schemas.microsoft.com/office/drawing/2014/main" id="{405BDD0A-B236-A578-D4D6-219FFE80B4A5}"/>
+              </a:ext>
+            </a:extLst>
+          </p:cNvPr>
           <p:cNvSpPr/>
           <p:nvPr/>
         </p:nvSpPr>
@@ -8644,7 +9621,13 @@
       </p:sp>
       <p:sp>
         <p:nvSpPr>
-          <p:cNvPr id="6" name="Shape 4"/>
+          <p:cNvPr id="6" name="Shape 4">
+            <a:extLst>
+              <a:ext uri="{FF2B5EF4-FFF2-40B4-BE49-F238E27FC236}">
+                <a16:creationId xmlns:a16="http://schemas.microsoft.com/office/drawing/2014/main" id="{511428D9-E84E-4D6C-DBA3-BE3E4637BDD4}"/>
+              </a:ext>
+            </a:extLst>
+          </p:cNvPr>
           <p:cNvSpPr/>
           <p:nvPr/>
         </p:nvSpPr>
@@ -8701,7 +9684,13 @@
       </p:sp>
       <p:sp>
         <p:nvSpPr>
-          <p:cNvPr id="7" name="Shape 5"/>
+          <p:cNvPr id="7" name="Shape 5">
+            <a:extLst>
+              <a:ext uri="{FF2B5EF4-FFF2-40B4-BE49-F238E27FC236}">
+                <a16:creationId xmlns:a16="http://schemas.microsoft.com/office/drawing/2014/main" id="{DDBCFBC4-4DDF-DA3F-A853-315E4A49EE57}"/>
+              </a:ext>
+            </a:extLst>
+          </p:cNvPr>
           <p:cNvSpPr/>
           <p:nvPr/>
         </p:nvSpPr>
@@ -8758,7 +9747,13 @@
       </p:sp>
       <p:sp>
         <p:nvSpPr>
-          <p:cNvPr id="8" name="Shape 6"/>
+          <p:cNvPr id="8" name="Shape 6">
+            <a:extLst>
+              <a:ext uri="{FF2B5EF4-FFF2-40B4-BE49-F238E27FC236}">
+                <a16:creationId xmlns:a16="http://schemas.microsoft.com/office/drawing/2014/main" id="{34C710AC-E007-C38C-32A0-526D4B362C7D}"/>
+              </a:ext>
+            </a:extLst>
+          </p:cNvPr>
           <p:cNvSpPr/>
           <p:nvPr/>
         </p:nvSpPr>
@@ -8815,7 +9810,13 @@
       </p:sp>
       <p:sp>
         <p:nvSpPr>
-          <p:cNvPr id="9" name="Shape 7"/>
+          <p:cNvPr id="9" name="Shape 7">
+            <a:extLst>
+              <a:ext uri="{FF2B5EF4-FFF2-40B4-BE49-F238E27FC236}">
+                <a16:creationId xmlns:a16="http://schemas.microsoft.com/office/drawing/2014/main" id="{6D63301B-A088-9B7A-637D-BFD886E188AA}"/>
+              </a:ext>
+            </a:extLst>
+          </p:cNvPr>
           <p:cNvSpPr/>
           <p:nvPr/>
         </p:nvSpPr>
@@ -8872,7 +9873,13 @@
       </p:sp>
       <p:sp>
         <p:nvSpPr>
-          <p:cNvPr id="10" name="Shape 8"/>
+          <p:cNvPr id="10" name="Shape 8">
+            <a:extLst>
+              <a:ext uri="{FF2B5EF4-FFF2-40B4-BE49-F238E27FC236}">
+                <a16:creationId xmlns:a16="http://schemas.microsoft.com/office/drawing/2014/main" id="{024FFF8C-41F0-2E13-D1F7-03EA0D26E055}"/>
+              </a:ext>
+            </a:extLst>
+          </p:cNvPr>
           <p:cNvSpPr/>
           <p:nvPr/>
         </p:nvSpPr>
@@ -8929,7 +9936,13 @@
       </p:sp>
       <p:sp>
         <p:nvSpPr>
-          <p:cNvPr id="11" name="Text 9"/>
+          <p:cNvPr id="11" name="Text 9">
+            <a:extLst>
+              <a:ext uri="{FF2B5EF4-FFF2-40B4-BE49-F238E27FC236}">
+                <a16:creationId xmlns:a16="http://schemas.microsoft.com/office/drawing/2014/main" id="{C9B12F82-C060-7FAB-935D-E0D05F303E6B}"/>
+              </a:ext>
+            </a:extLst>
+          </p:cNvPr>
           <p:cNvSpPr>
             <a:spLocks noGrp="1"/>
           </p:cNvSpPr>
@@ -8939,7 +9952,7 @@
         </p:nvSpPr>
         <p:spPr>
           <a:xfrm>
-            <a:off x="812800" y="2771142"/>
+            <a:off x="812800" y="1903254"/>
             <a:ext cx="7194550" cy="695960"/>
           </a:xfrm>
           <a:prstGeom prst="rect">
@@ -8969,7 +9982,7 @@
                 <a:ea typeface="Libre Baskerville" pitchFamily="18" charset="-122"/>
                 <a:cs typeface="Libre Baskerville" pitchFamily="18" charset="-120"/>
               </a:rPr>
-              <a:t>Thank you</a:t>
+              <a:t>References</a:t>
             </a:r>
             <a:endParaRPr lang="en-US" sz="4800" dirty="0"/>
           </a:p>
@@ -8977,13 +9990,19 @@
       </p:sp>
       <p:sp>
         <p:nvSpPr>
-          <p:cNvPr id="12" name="Text 10"/>
+          <p:cNvPr id="12" name="Text 10">
+            <a:extLst>
+              <a:ext uri="{FF2B5EF4-FFF2-40B4-BE49-F238E27FC236}">
+                <a16:creationId xmlns:a16="http://schemas.microsoft.com/office/drawing/2014/main" id="{FEA7D988-DB18-BF31-FEA6-4C1D2660D0C9}"/>
+              </a:ext>
+            </a:extLst>
+          </p:cNvPr>
           <p:cNvSpPr/>
           <p:nvPr/>
         </p:nvSpPr>
         <p:spPr>
           <a:xfrm>
-            <a:off x="812800" y="3695700"/>
+            <a:off x="812800" y="3012440"/>
             <a:ext cx="7194550" cy="416560"/>
           </a:xfrm>
           <a:prstGeom prst="rect">
@@ -8994,34 +10013,17 @@
         </p:spPr>
         <p:txBody>
           <a:bodyPr wrap="square" lIns="0" tIns="0" rIns="0" bIns="0" rtlCol="0" anchor="t">
-            <a:normAutofit/>
+            <a:noAutofit/>
           </a:bodyPr>
           <a:lstStyle/>
           <a:p>
-            <a:pPr marL="0" marR="0" lvl="0" indent="0" algn="l" defTabSz="914400" rtl="0" eaLnBrk="1" fontAlgn="auto" latinLnBrk="0" hangingPunct="1">
-              <a:lnSpc>
-                <a:spcPts val="3080"/>
-              </a:lnSpc>
-              <a:spcBef>
-                <a:spcPts val="0"/>
-              </a:spcBef>
-              <a:spcAft>
-                <a:spcPts val="0"/>
-              </a:spcAft>
-              <a:buClrTx/>
-              <a:buSzTx/>
-              <a:buFontTx/>
-              <a:buNone/>
-              <a:tabLst/>
-              <a:defRPr/>
-            </a:pPr>
             <a:r>
-              <a:rPr kumimoji="0" lang="en-US" sz="2200" b="0" i="0" u="none" strike="noStrike" kern="1200" cap="none" spc="0" normalizeH="0" baseline="0" noProof="0" dirty="0">
+              <a:rPr kumimoji="0" lang="en-US" sz="1200" b="0" i="0" u="none" strike="noStrike" kern="1200" cap="none" spc="0" normalizeH="0" baseline="0" noProof="0" dirty="0">
                 <a:ln>
                   <a:noFill/>
                 </a:ln>
                 <a:solidFill>
-                  <a:srgbClr val="E39BBE"/>
+                  <a:schemeClr val="accent2"/>
                 </a:solidFill>
                 <a:effectLst/>
                 <a:uLnTx/>
@@ -9030,14 +10032,191 @@
                 <a:ea typeface="Public Sans" pitchFamily="34" charset="-122"/>
                 <a:cs typeface="Public Sans" pitchFamily="34" charset="-120"/>
               </a:rPr>
-              <a:t>Questions?</a:t>
+              <a:t>1. </a:t>
             </a:r>
-            <a:endParaRPr kumimoji="0" lang="en-US" sz="2200" b="0" i="0" u="none" strike="noStrike" kern="1200" cap="none" spc="0" normalizeH="0" baseline="0" noProof="0" dirty="0">
+            <a:r>
+              <a:rPr lang="en-CA" sz="1200" i="1" dirty="0">
+                <a:solidFill>
+                  <a:schemeClr val="bg1"/>
+                </a:solidFill>
+              </a:rPr>
+              <a:t>Traffic Incidents | Open Calgary</a:t>
+            </a:r>
+            <a:r>
+              <a:rPr lang="en-CA" sz="1200" dirty="0">
+                <a:solidFill>
+                  <a:schemeClr val="bg1"/>
+                </a:solidFill>
+              </a:rPr>
+              <a:t>. </a:t>
+            </a:r>
+          </a:p>
+          <a:p>
+            <a:r>
+              <a:rPr lang="en-CA" sz="1200" dirty="0">
+                <a:solidFill>
+                  <a:schemeClr val="bg1"/>
+                </a:solidFill>
+                <a:hlinkClick r:id="rId3"/>
+              </a:rPr>
+              <a:t>https://data.calgary.ca/Transportation-Transit/Traffic-Incidents/35ra-9556/about_data</a:t>
+            </a:r>
+            <a:endParaRPr lang="en-CA" sz="1200" dirty="0">
+              <a:solidFill>
+                <a:schemeClr val="bg1"/>
+              </a:solidFill>
+            </a:endParaRPr>
+          </a:p>
+          <a:p>
+            <a:endParaRPr kumimoji="0" lang="en-US" sz="1200" b="0" i="0" u="none" strike="noStrike" kern="1200" cap="none" spc="0" normalizeH="0" baseline="0" noProof="0" dirty="0">
               <a:ln>
                 <a:noFill/>
               </a:ln>
               <a:solidFill>
-                <a:srgbClr val="2B2B30"/>
+                <a:schemeClr val="bg1"/>
+              </a:solidFill>
+              <a:effectLst/>
+              <a:uLnTx/>
+              <a:uFillTx/>
+              <a:latin typeface="Public Sans" pitchFamily="34" charset="0"/>
+              <a:ea typeface="Public Sans" pitchFamily="34" charset="-122"/>
+              <a:cs typeface="Public Sans" pitchFamily="34" charset="-120"/>
+            </a:endParaRPr>
+          </a:p>
+          <a:p>
+            <a:r>
+              <a:rPr lang="en-US" sz="1200" dirty="0">
+                <a:solidFill>
+                  <a:schemeClr val="accent2"/>
+                </a:solidFill>
+                <a:latin typeface="Public Sans" pitchFamily="34" charset="0"/>
+                <a:ea typeface="Public Sans" pitchFamily="34" charset="-122"/>
+              </a:rPr>
+              <a:t>2. </a:t>
+            </a:r>
+            <a:r>
+              <a:rPr lang="en-CA" sz="1200" i="1" dirty="0">
+                <a:solidFill>
+                  <a:schemeClr val="bg1"/>
+                </a:solidFill>
+              </a:rPr>
+              <a:t>Calgary Equity Index Overlay Statistics | Open Calgary</a:t>
+            </a:r>
+            <a:r>
+              <a:rPr lang="en-CA" sz="1200" dirty="0">
+                <a:solidFill>
+                  <a:schemeClr val="bg1"/>
+                </a:solidFill>
+              </a:rPr>
+              <a:t>. </a:t>
+            </a:r>
+          </a:p>
+          <a:p>
+            <a:r>
+              <a:rPr lang="en-CA" sz="1200" dirty="0">
+                <a:solidFill>
+                  <a:schemeClr val="bg1"/>
+                </a:solidFill>
+                <a:hlinkClick r:id="rId4"/>
+              </a:rPr>
+              <a:t>https://data.calgary.ca/Demographics/Calgary-Equity-Index-Overlay-Statistics/7g5f-dkmi/about_data</a:t>
+            </a:r>
+            <a:endParaRPr lang="en-CA" sz="1200" dirty="0">
+              <a:solidFill>
+                <a:schemeClr val="bg1"/>
+              </a:solidFill>
+            </a:endParaRPr>
+          </a:p>
+          <a:p>
+            <a:endParaRPr lang="en-CA" sz="1200" dirty="0">
+              <a:solidFill>
+                <a:schemeClr val="bg1"/>
+              </a:solidFill>
+            </a:endParaRPr>
+          </a:p>
+          <a:p>
+            <a:pPr lvl="0">
+              <a:defRPr/>
+            </a:pPr>
+            <a:r>
+              <a:rPr kumimoji="0" lang="en-US" sz="1200" b="0" i="0" u="none" strike="noStrike" kern="1200" cap="none" spc="0" normalizeH="0" baseline="0" noProof="0" dirty="0">
+                <a:ln>
+                  <a:noFill/>
+                </a:ln>
+                <a:solidFill>
+                  <a:schemeClr val="accent2"/>
+                </a:solidFill>
+                <a:effectLst/>
+                <a:uLnTx/>
+                <a:uFillTx/>
+                <a:latin typeface="Public Sans" pitchFamily="34" charset="0"/>
+                <a:ea typeface="Public Sans" pitchFamily="34" charset="-122"/>
+                <a:cs typeface="+mn-cs"/>
+              </a:rPr>
+              <a:t>3.</a:t>
+            </a:r>
+            <a:r>
+              <a:rPr lang="en-CA" sz="1200" i="1" dirty="0">
+                <a:solidFill>
+                  <a:schemeClr val="accent2"/>
+                </a:solidFill>
+              </a:rPr>
+              <a:t> </a:t>
+            </a:r>
+            <a:r>
+              <a:rPr lang="en-CA" sz="1200" i="1" dirty="0">
+                <a:solidFill>
+                  <a:schemeClr val="bg1"/>
+                </a:solidFill>
+              </a:rPr>
+              <a:t>Community District Boundaries | Open Calgary</a:t>
+            </a:r>
+            <a:r>
+              <a:rPr lang="en-CA" sz="1200" dirty="0">
+                <a:solidFill>
+                  <a:schemeClr val="bg1"/>
+                </a:solidFill>
+              </a:rPr>
+              <a:t>. </a:t>
+            </a:r>
+          </a:p>
+          <a:p>
+            <a:pPr lvl="0">
+              <a:defRPr/>
+            </a:pPr>
+            <a:r>
+              <a:rPr lang="en-CA" sz="1200" dirty="0">
+                <a:solidFill>
+                  <a:schemeClr val="bg1"/>
+                </a:solidFill>
+                <a:hlinkClick r:id="rId5"/>
+              </a:rPr>
+              <a:t>https://data.calgary.ca/Base-Maps/Community-District-Boundaries/surr-xmvs/about_data</a:t>
+            </a:r>
+            <a:endParaRPr lang="en-CA" sz="1200" dirty="0">
+              <a:solidFill>
+                <a:schemeClr val="bg1"/>
+              </a:solidFill>
+            </a:endParaRPr>
+          </a:p>
+          <a:p>
+            <a:pPr lvl="0">
+              <a:defRPr/>
+            </a:pPr>
+            <a:r>
+              <a:rPr lang="en-CA" sz="1200" dirty="0">
+                <a:solidFill>
+                  <a:schemeClr val="bg1"/>
+                </a:solidFill>
+              </a:rPr>
+              <a:t> </a:t>
+            </a:r>
+            <a:endParaRPr kumimoji="0" lang="en-US" sz="1200" b="0" i="0" u="none" strike="noStrike" kern="1200" cap="none" spc="0" normalizeH="0" baseline="0" noProof="0" dirty="0">
+              <a:ln>
+                <a:noFill/>
+              </a:ln>
+              <a:solidFill>
+                <a:schemeClr val="bg1"/>
               </a:solidFill>
               <a:effectLst/>
               <a:uLnTx/>
@@ -9050,7 +10229,13 @@
       </p:sp>
       <p:sp>
         <p:nvSpPr>
-          <p:cNvPr id="13" name="Text 11"/>
+          <p:cNvPr id="13" name="Text 11">
+            <a:extLst>
+              <a:ext uri="{FF2B5EF4-FFF2-40B4-BE49-F238E27FC236}">
+                <a16:creationId xmlns:a16="http://schemas.microsoft.com/office/drawing/2014/main" id="{1F7DB7C1-3A06-650E-5DEB-813E2D7AFFAA}"/>
+              </a:ext>
+            </a:extLst>
+          </p:cNvPr>
           <p:cNvSpPr/>
           <p:nvPr/>
         </p:nvSpPr>
@@ -9106,6 +10291,11 @@
         </p:txBody>
       </p:sp>
     </p:spTree>
+    <p:extLst>
+      <p:ext uri="{BB962C8B-B14F-4D97-AF65-F5344CB8AC3E}">
+        <p14:creationId xmlns:p14="http://schemas.microsoft.com/office/powerpoint/2010/main" val="616101780"/>
+      </p:ext>
+    </p:extLst>
   </p:cSld>
   <p:clrMapOvr>
     <a:masterClrMapping/>

</xml_diff>